<commit_message>
Add cube logo, copper accent and verified market sources to pitch
New GEN³ Works mark: an isometric cube whose three faces stand for
現場・現物・現実, with a copper top face. The logotype now sits at the
bottom right of every pitch slide (the cover uses its own layout),
chapter numbers and the ask use the copper accent, and the demo app
uses the same mark. Market figures now cite IMARC's Japan Smart
Factory report (9.03% CAGR) and Yano's ConTech release No.3789
(building sector, 7.4% CAGR), and the electrical-works count uses the
2025 figure. The cost slide proposes Kawasaki as the office location.

Co-Authored-By: Claude Opus 5.5 <noreply@anthropic.com>
Claude-Session: https://claude.ai/code/session_01Lvjvqoc8h4yHt4F4M6n1V9
</commit_message>
<xml_diff>
--- a/deck/令和の虎_事業計画書_三現ワークス.pptx
+++ b/deck/令和の虎_事業計画書_三現ワークス.pptx
@@ -3575,7 +3575,7 @@
               <a:rPr lang="en-US" dirty="0"/>
               <a:t>【3:50 - 4:30】
 要約：狙う市場は約100億円。周辺市場は年7〜9%で伸びている
-市場規模です。土台となる国内のスマートファクトリー市場は、2025年の42億ドルから年9%で伸びる見込みです。建設テック市場も2030年度に3,000億円を超えます。当社が狙うのは、電線・ケーブル工場の353事業所と、中堅以上の電気工事会社約3,000社。年300万円をかけると約100億円の市場です。5年目に85拠点、シェア2.5%を取りに行きます。</a:t>
+市場規模です。土台となる国内のスマートファクトリー市場は、2025年の42億ドルから年9%で伸びる見込みです。建設テック市場も、建築分野だけで2030年度に約3,040億円、年7.4%の成長です。当社が狙うのは、電線・ケーブル工場の353事業所と、中堅以上の電気工事会社約3,000社。年300万円をかけると約100億円の市場です。5年目に85拠点、シェア2.5%を取りに行きます。</a:t>
             </a:r>
             <a:endParaRPr lang="en-US" dirty="0"/>
           </a:p>
@@ -3755,7 +3755,7 @@
               <a:rPr lang="en-US" dirty="0"/>
               <a:t>【5:15 - 5:55】
 要約：売上は拠点数×月25万円で積み上がる。5年目は月2,400万円
-売上と費用です。売上は、拠点数かける月25万円の利用料が積み上がる形です。5年目の月次売上は約2,400万円で、内訳は利用料が約1,790万円、導入支援が約550万円です。費用の中心は人件費で、1人あたり年800万円。家賃は1年目月20万円、5年目月50万円、広告と展示会は1年目200万円から5年目500万円を見込んでいます。</a:t>
+売上と費用です。売上は、拠点数かける月25万円の利用料が積み上がる形です。5年目の月次売上は約2,400万円で、内訳は利用料が約1,790万円、導入支援が約550万円です。費用の中心は人件費で、1人あたり年800万円。所在地は川崎市を考えています。京浜の工場地帯と羽田・新幹線に近く、関東の電線工場と東京の電気工事会社の両方に出やすい場所です。家賃は1年目15坪で月20万円、5年目40坪で月50万円、広告と展示会は1年目200万円から5年目500万円を見込んでいます。</a:t>
             </a:r>
             <a:endParaRPr lang="en-US" dirty="0"/>
           </a:p>
@@ -3867,8 +3867,8 @@
         </p:blipFill>
         <p:spPr>
           <a:xfrm>
-            <a:off x="8613648" y="201168"/>
-            <a:ext cx="274320" cy="274320"/>
+            <a:off x="7452360" y="4754880"/>
+            <a:ext cx="1325880" cy="284117"/>
           </a:xfrm>
           <a:prstGeom prst="rect">
             <a:avLst/>
@@ -3883,8 +3883,8 @@
         </p:nvSpPr>
         <p:spPr>
           <a:xfrm>
-            <a:off x="5760720" y="4846320"/>
-            <a:ext cx="2651760" cy="201168"/>
+            <a:off x="731520" y="4837176"/>
+            <a:ext cx="3200400" cy="201168"/>
           </a:xfrm>
           <a:prstGeom prst="rect">
             <a:avLst/>
@@ -3896,7 +3896,7 @@
           <a:bodyPr wrap="square" lIns="0" tIns="0" rIns="0" bIns="0" rtlCol="0" anchor="ctr"/>
           <a:lstStyle/>
           <a:p>
-            <a:pPr algn="r" indent="0" marL="0">
+            <a:pPr algn="l" indent="0" marL="0">
               <a:buNone/>
             </a:pPr>
             <a:r>
@@ -3926,8 +3926,8 @@
         </p:nvSpPr>
         <p:spPr>
           <a:xfrm>
-            <a:off x="8503920" y="4846320"/>
-            <a:ext cx="365760" cy="201168"/>
+            <a:off x="365760" y="4837176"/>
+            <a:ext cx="320040" cy="201168"/>
           </a:xfrm>
           <a:prstGeom prst="rect">
             <a:avLst/>
@@ -3953,7 +3953,7 @@
             </a:lvl1pPr>
           </a:lstStyle>
           <a:p>
-            <a:pPr algn="r"/>
+            <a:pPr algn="l"/>
             <a:fld id="{F7021451-1387-4CA6-816F-3879F97B5CBC}" type="slidenum">
               <a:rPr b="0" lang="en-US"/>
               <a:t>1002</a:t>
@@ -3962,6 +3962,62 @@
           </a:p>
         </p:txBody>
       </p:sp>
+    </p:spTree>
+  </p:cSld>
+  <p:clrMapOvr>
+    <a:masterClrMapping/>
+  </p:clrMapOvr>
+</p:sldLayout>
+</file>
+
+<file path=ppt/slideLayouts/slideLayout3.xml><?xml version="1.0" encoding="utf-8"?>
+<p:sldLayout xmlns:a="http://schemas.openxmlformats.org/drawingml/2006/main" xmlns:r="http://schemas.openxmlformats.org/officeDocument/2006/relationships" xmlns:p="http://schemas.openxmlformats.org/presentationml/2006/main" preserve="1">
+  <p:cSld name="GR_COVER">
+    <p:bg>
+      <p:bgPr>
+        <a:solidFill>
+          <a:srgbClr val="FFFFFF"/>
+        </a:solidFill>
+      </p:bgPr>
+    </p:bg>
+    <p:spTree>
+      <p:nvGrpSpPr>
+        <p:cNvPr id="1" name=""/>
+        <p:cNvGrpSpPr/>
+        <p:nvPr/>
+      </p:nvGrpSpPr>
+      <p:grpSpPr>
+        <a:xfrm>
+          <a:off x="0" y="0"/>
+          <a:ext cx="0" cy="0"/>
+          <a:chOff x="0" y="0"/>
+          <a:chExt cx="0" cy="0"/>
+        </a:xfrm>
+      </p:grpSpPr>
+      <p:pic>
+        <p:nvPicPr>
+          <p:cNvPr id="2" name="Image 0" descr="preencoded.png">    </p:cNvPr>
+          <p:cNvPicPr>
+            <a:picLocks noChangeAspect="1"/>
+          </p:cNvPicPr>
+          <p:nvPr/>
+        </p:nvPicPr>
+        <p:blipFill>
+          <a:blip r:embed="rId1"/>
+          <a:stretch>
+            <a:fillRect/>
+          </a:stretch>
+        </p:blipFill>
+        <p:spPr>
+          <a:xfrm>
+            <a:off x="7452360" y="4754880"/>
+            <a:ext cx="1325880" cy="284117"/>
+          </a:xfrm>
+          <a:prstGeom prst="rect">
+            <a:avLst/>
+          </a:prstGeom>
+        </p:spPr>
+      </p:pic>
     </p:spTree>
   </p:cSld>
   <p:clrMapOvr>
@@ -3999,8 +4055,8 @@
         </p:nvSpPr>
         <p:spPr>
           <a:xfrm>
-            <a:off x="8503920" y="4846320"/>
-            <a:ext cx="365760" cy="201168"/>
+            <a:off x="365760" y="4837176"/>
+            <a:ext cx="320040" cy="201168"/>
           </a:xfrm>
           <a:prstGeom prst="rect">
             <a:avLst/>
@@ -4026,7 +4082,7 @@
             </a:lvl1pPr>
           </a:lstStyle>
           <a:p>
-            <a:pPr algn="r"/>
+            <a:pPr algn="l"/>
             <a:fld id="{F7021451-1387-4CA6-816F-3879F97B5CBC}" type="slidenum">
               <a:rPr b="0" lang="en-US"/>
               <a:t>null</a:t>
@@ -4041,6 +4097,7 @@
   <p:sldLayoutIdLst>
     <p:sldLayoutId id="2147483649" r:id="rId1"/>
     <p:sldLayoutId id="2147483650" r:id="rId2"/>
+    <p:sldLayoutId id="2147483651" r:id="rId3"/>
   </p:sldLayoutIdLst>
   <p:hf sldNum="0" hdr="0" ftr="0" dt="0"/>
   <p:txStyles>
@@ -4349,8 +4406,8 @@
         </p:blipFill>
         <p:spPr>
           <a:xfrm>
-            <a:off x="320040" y="1005840"/>
-            <a:ext cx="2651760" cy="640080"/>
+            <a:off x="320040" y="960120"/>
+            <a:ext cx="2743200" cy="587829"/>
           </a:xfrm>
           <a:prstGeom prst="rect">
             <a:avLst/>
@@ -4666,9 +4723,9 @@
           <a:solidFill>
             <a:srgbClr val="FFFFFF"/>
           </a:solidFill>
-          <a:ln w="19050">
+          <a:ln w="25400">
             <a:solidFill>
-              <a:srgbClr val="1A1A1A"/>
+              <a:srgbClr val="B8692E"/>
             </a:solidFill>
             <a:prstDash val="solid"/>
           </a:ln>
@@ -4746,7 +4803,7 @@
             <a:r>
               <a:rPr lang="en-US" sz="4400" b="1" dirty="0">
                 <a:solidFill>
-                  <a:srgbClr val="1A1A1A"/>
+                  <a:srgbClr val="B8692E"/>
                 </a:solidFill>
                 <a:latin typeface="Meiryo" pitchFamily="34" charset="0"/>
                 <a:ea typeface="Meiryo" pitchFamily="34" charset="-122"/>
@@ -4859,54 +4916,6 @@
               <a:t>志願者：＿＿＿＿＿＿＿＿＿＿</a:t>
             </a:r>
             <a:endParaRPr lang="en-US" sz="1050" dirty="0"/>
-          </a:p>
-        </p:txBody>
-      </p:sp>
-      <p:sp>
-        <p:nvSpPr>
-          <p:cNvPr id="25" name="Slide Number Placeholder 0"/>
-          <p:cNvSpPr>
-            <a:spLocks noGrp="1"/>
-          </p:cNvSpPr>
-          <p:nvPr>
-            <p:ph type="sldNum" sz="quarter" idx="4294967295"/>
-          </p:nvPr>
-        </p:nvSpPr>
-        <p:spPr>
-          <a:xfrm>
-            <a:off x="8503920" y="4846320"/>
-            <a:ext cx="365760" cy="201168"/>
-          </a:xfrm>
-          <a:prstGeom prst="rect">
-            <a:avLst/>
-          </a:prstGeom>
-          <a:extLst>
-            <a:ext uri="{C572A759-6A51-4108-AA02-DFA0A04FC94B}">
-              <ma14:wrappingTextBoxFlag xmlns:ma14="http://schemas.microsoft.com/office/mac/drawingml/2011/main" val="0"/>
-            </a:ext>
-          </a:extLst>
-        </p:spPr>
-        <p:txBody>
-          <a:bodyPr lIns="0" tIns="0" rIns="0" bIns="0"/>
-          <a:lstStyle>
-            <a:lvl1pPr>
-              <a:defRPr sz="850">
-                <a:solidFill>
-                  <a:srgbClr val="8C8C8C"/>
-                </a:solidFill>
-                <a:latin typeface="Meiryo"/>
-                <a:ea typeface="Meiryo"/>
-                <a:cs typeface="Meiryo"/>
-              </a:defRPr>
-            </a:lvl1pPr>
-          </a:lstStyle>
-          <a:p>
-            <a:pPr algn="r"/>
-            <a:fld id="{F7021451-1387-4CA6-816F-3879F97B5CBC}" type="slidenum">
-              <a:rPr b="0" lang="en-US"/>
-              <a:t>1</a:t>
-            </a:fld>
-            <a:endParaRPr lang="en-US"/>
           </a:p>
         </p:txBody>
       </p:sp>
@@ -4965,13 +4974,30 @@
             <a:r>
               <a:rPr lang="en-US" sz="2000" b="1" dirty="0">
                 <a:solidFill>
+                  <a:srgbClr val="B8692E"/>
+                </a:solidFill>
+                <a:latin typeface="Meiryo" pitchFamily="34" charset="0"/>
+                <a:ea typeface="Meiryo" pitchFamily="34" charset="-122"/>
+                <a:cs typeface="Meiryo" pitchFamily="34" charset="-120"/>
+              </a:rPr>
+              <a:t>⑥ </a:t>
+            </a:r>
+            <a:pPr algn="l" indent="0" marL="0">
+              <a:lnSpc>
+                <a:spcPct val="115000"/>
+              </a:lnSpc>
+              <a:buNone/>
+            </a:pPr>
+            <a:r>
+              <a:rPr lang="en-US" sz="2000" b="1" dirty="0">
+                <a:solidFill>
                   <a:srgbClr val="1A1A1A"/>
                 </a:solidFill>
                 <a:latin typeface="Meiryo" pitchFamily="34" charset="0"/>
                 <a:ea typeface="Meiryo" pitchFamily="34" charset="-122"/>
                 <a:cs typeface="Meiryo" pitchFamily="34" charset="-120"/>
               </a:rPr>
-              <a:t>⑥ 損益分岐点 ─ 4年目に超え、5年目の余裕率は32%</a:t>
+              <a:t>損益分岐点 ─ 4年目に超え、5年目の余裕率は32%</a:t>
             </a:r>
             <a:endParaRPr lang="en-US" sz="2000" dirty="0"/>
           </a:p>
@@ -6550,8 +6576,8 @@
         </p:nvSpPr>
         <p:spPr>
           <a:xfrm>
-            <a:off x="8503920" y="4846320"/>
-            <a:ext cx="365760" cy="201168"/>
+            <a:off x="365760" y="4837176"/>
+            <a:ext cx="320040" cy="201168"/>
           </a:xfrm>
           <a:prstGeom prst="rect">
             <a:avLst/>
@@ -6577,7 +6603,7 @@
             </a:lvl1pPr>
           </a:lstStyle>
           <a:p>
-            <a:pPr algn="r"/>
+            <a:pPr algn="l"/>
             <a:fld id="{F7021451-1387-4CA6-816F-3879F97B5CBC}" type="slidenum">
               <a:rPr b="0" lang="en-US"/>
               <a:t>10</a:t>
@@ -6641,13 +6667,30 @@
             <a:r>
               <a:rPr lang="en-US" sz="2000" b="1" dirty="0">
                 <a:solidFill>
+                  <a:srgbClr val="B8692E"/>
+                </a:solidFill>
+                <a:latin typeface="Meiryo" pitchFamily="34" charset="0"/>
+                <a:ea typeface="Meiryo" pitchFamily="34" charset="-122"/>
+                <a:cs typeface="Meiryo" pitchFamily="34" charset="-120"/>
+              </a:rPr>
+              <a:t>⑥ </a:t>
+            </a:r>
+            <a:pPr algn="l" indent="0" marL="0">
+              <a:lnSpc>
+                <a:spcPct val="115000"/>
+              </a:lnSpc>
+              <a:buNone/>
+            </a:pPr>
+            <a:r>
+              <a:rPr lang="en-US" sz="2000" b="1" dirty="0">
+                <a:solidFill>
                   <a:srgbClr val="1A1A1A"/>
                 </a:solidFill>
                 <a:latin typeface="Meiryo" pitchFamily="34" charset="0"/>
                 <a:ea typeface="Meiryo" pitchFamily="34" charset="-122"/>
                 <a:cs typeface="Meiryo" pitchFamily="34" charset="-120"/>
               </a:rPr>
-              <a:t>⑥ 資金計画・CF ─ 黒字倒産させない仕組みを先に置く</a:t>
+              <a:t>資金計画・CF ─ 黒字倒産させない仕組みを先に置く</a:t>
             </a:r>
             <a:endParaRPr lang="en-US" sz="2000" dirty="0"/>
           </a:p>
@@ -8351,8 +8394,8 @@
         </p:nvSpPr>
         <p:spPr>
           <a:xfrm>
-            <a:off x="8503920" y="4846320"/>
-            <a:ext cx="365760" cy="201168"/>
+            <a:off x="365760" y="4837176"/>
+            <a:ext cx="320040" cy="201168"/>
           </a:xfrm>
           <a:prstGeom prst="rect">
             <a:avLst/>
@@ -8378,7 +8421,7 @@
             </a:lvl1pPr>
           </a:lstStyle>
           <a:p>
-            <a:pPr algn="r"/>
+            <a:pPr algn="l"/>
             <a:fld id="{F7021451-1387-4CA6-816F-3879F97B5CBC}" type="slidenum">
               <a:rPr b="0" lang="en-US"/>
               <a:t>11</a:t>
@@ -8442,13 +8485,30 @@
             <a:r>
               <a:rPr lang="en-US" sz="2000" b="1" dirty="0">
                 <a:solidFill>
+                  <a:srgbClr val="B8692E"/>
+                </a:solidFill>
+                <a:latin typeface="Meiryo" pitchFamily="34" charset="0"/>
+                <a:ea typeface="Meiryo" pitchFamily="34" charset="-122"/>
+                <a:cs typeface="Meiryo" pitchFamily="34" charset="-120"/>
+              </a:rPr>
+              <a:t>⑦ </a:t>
+            </a:r>
+            <a:pPr algn="l" indent="0" marL="0">
+              <a:lnSpc>
+                <a:spcPct val="115000"/>
+              </a:lnSpc>
+              <a:buNone/>
+            </a:pPr>
+            <a:r>
+              <a:rPr lang="en-US" sz="2000" b="1" dirty="0">
+                <a:solidFill>
                   <a:srgbClr val="1A1A1A"/>
                 </a:solidFill>
                 <a:latin typeface="Meiryo" pitchFamily="34" charset="0"/>
                 <a:ea typeface="Meiryo" pitchFamily="34" charset="-122"/>
                 <a:cs typeface="Meiryo" pitchFamily="34" charset="-120"/>
               </a:rPr>
-              <a:t>⑦ チーム ─ 現場と技術を揃え、顧問とパートナーで補う</a:t>
+              <a:t>チーム ─ 現場と技術を揃え、顧問とパートナーで補う</a:t>
             </a:r>
             <a:endParaRPr lang="en-US" sz="2000" dirty="0"/>
           </a:p>
@@ -10336,8 +10396,8 @@
         </p:nvSpPr>
         <p:spPr>
           <a:xfrm>
-            <a:off x="8503920" y="4846320"/>
-            <a:ext cx="365760" cy="201168"/>
+            <a:off x="365760" y="4837176"/>
+            <a:ext cx="320040" cy="201168"/>
           </a:xfrm>
           <a:prstGeom prst="rect">
             <a:avLst/>
@@ -10363,7 +10423,7 @@
             </a:lvl1pPr>
           </a:lstStyle>
           <a:p>
-            <a:pPr algn="r"/>
+            <a:pPr algn="l"/>
             <a:fld id="{F7021451-1387-4CA6-816F-3879F97B5CBC}" type="slidenum">
               <a:rPr b="0" lang="en-US"/>
               <a:t>12</a:t>
@@ -11259,8 +11319,8 @@
         </p:nvSpPr>
         <p:spPr>
           <a:xfrm>
-            <a:off x="8503920" y="4846320"/>
-            <a:ext cx="365760" cy="201168"/>
+            <a:off x="365760" y="4837176"/>
+            <a:ext cx="320040" cy="201168"/>
           </a:xfrm>
           <a:prstGeom prst="rect">
             <a:avLst/>
@@ -11286,7 +11346,7 @@
             </a:lvl1pPr>
           </a:lstStyle>
           <a:p>
-            <a:pPr algn="r"/>
+            <a:pPr algn="l"/>
             <a:fld id="{F7021451-1387-4CA6-816F-3879F97B5CBC}" type="slidenum">
               <a:rPr b="0" lang="en-US"/>
               <a:t>13</a:t>
@@ -12723,8 +12783,8 @@
         </p:nvSpPr>
         <p:spPr>
           <a:xfrm>
-            <a:off x="8503920" y="4846320"/>
-            <a:ext cx="365760" cy="201168"/>
+            <a:off x="365760" y="4837176"/>
+            <a:ext cx="320040" cy="201168"/>
           </a:xfrm>
           <a:prstGeom prst="rect">
             <a:avLst/>
@@ -12750,7 +12810,7 @@
             </a:lvl1pPr>
           </a:lstStyle>
           <a:p>
-            <a:pPr algn="r"/>
+            <a:pPr algn="l"/>
             <a:fld id="{F7021451-1387-4CA6-816F-3879F97B5CBC}" type="slidenum">
               <a:rPr b="0" lang="en-US"/>
               <a:t>14</a:t>
@@ -13542,8 +13602,8 @@
         </p:nvSpPr>
         <p:spPr>
           <a:xfrm>
-            <a:off x="8503920" y="4846320"/>
-            <a:ext cx="365760" cy="201168"/>
+            <a:off x="365760" y="4837176"/>
+            <a:ext cx="320040" cy="201168"/>
           </a:xfrm>
           <a:prstGeom prst="rect">
             <a:avLst/>
@@ -13569,7 +13629,7 @@
             </a:lvl1pPr>
           </a:lstStyle>
           <a:p>
-            <a:pPr algn="r"/>
+            <a:pPr algn="l"/>
             <a:fld id="{F7021451-1387-4CA6-816F-3879F97B5CBC}" type="slidenum">
               <a:rPr b="0" lang="en-US"/>
               <a:t>15</a:t>
@@ -13633,13 +13693,30 @@
             <a:r>
               <a:rPr lang="en-US" sz="2000" b="1" dirty="0">
                 <a:solidFill>
+                  <a:srgbClr val="B8692E"/>
+                </a:solidFill>
+                <a:latin typeface="Meiryo" pitchFamily="34" charset="0"/>
+                <a:ea typeface="Meiryo" pitchFamily="34" charset="-122"/>
+                <a:cs typeface="Meiryo" pitchFamily="34" charset="-120"/>
+              </a:rPr>
+              <a:t>① </a:t>
+            </a:r>
+            <a:pPr algn="l" indent="0" marL="0">
+              <a:lnSpc>
+                <a:spcPct val="115000"/>
+              </a:lnSpc>
+              <a:buNone/>
+            </a:pPr>
+            <a:r>
+              <a:rPr lang="en-US" sz="2000" b="1" dirty="0">
+                <a:solidFill>
                   <a:srgbClr val="1A1A1A"/>
                 </a:solidFill>
                 <a:latin typeface="Meiryo" pitchFamily="34" charset="0"/>
                 <a:ea typeface="Meiryo" pitchFamily="34" charset="-122"/>
                 <a:cs typeface="Meiryo" pitchFamily="34" charset="-120"/>
               </a:rPr>
-              <a:t>① 事業概要 ─ 現場の作業を記録し、報告と教育を自動に</a:t>
+              <a:t>事業概要 ─ 現場の作業を記録し、報告と教育を自動に</a:t>
             </a:r>
             <a:endParaRPr lang="en-US" sz="2000" dirty="0"/>
           </a:p>
@@ -14157,8 +14234,8 @@
         </p:nvSpPr>
         <p:spPr>
           <a:xfrm>
-            <a:off x="8503920" y="4846320"/>
-            <a:ext cx="365760" cy="201168"/>
+            <a:off x="365760" y="4837176"/>
+            <a:ext cx="320040" cy="201168"/>
           </a:xfrm>
           <a:prstGeom prst="rect">
             <a:avLst/>
@@ -14184,7 +14261,7 @@
             </a:lvl1pPr>
           </a:lstStyle>
           <a:p>
-            <a:pPr algn="r"/>
+            <a:pPr algn="l"/>
             <a:fld id="{F7021451-1387-4CA6-816F-3879F97B5CBC}" type="slidenum">
               <a:rPr b="0" lang="en-US"/>
               <a:t>2</a:t>
@@ -14248,13 +14325,30 @@
             <a:r>
               <a:rPr lang="en-US" sz="2000" b="1" dirty="0">
                 <a:solidFill>
+                  <a:srgbClr val="B8692E"/>
+                </a:solidFill>
+                <a:latin typeface="Meiryo" pitchFamily="34" charset="0"/>
+                <a:ea typeface="Meiryo" pitchFamily="34" charset="-122"/>
+                <a:cs typeface="Meiryo" pitchFamily="34" charset="-120"/>
+              </a:rPr>
+              <a:t>② </a:t>
+            </a:r>
+            <a:pPr algn="l" indent="0" marL="0">
+              <a:lnSpc>
+                <a:spcPct val="115000"/>
+              </a:lnSpc>
+              <a:buNone/>
+            </a:pPr>
+            <a:r>
+              <a:rPr lang="en-US" sz="2000" b="1" dirty="0">
+                <a:solidFill>
                   <a:srgbClr val="1A1A1A"/>
                 </a:solidFill>
                 <a:latin typeface="Meiryo" pitchFamily="34" charset="0"/>
                 <a:ea typeface="Meiryo" pitchFamily="34" charset="-122"/>
                 <a:cs typeface="Meiryo" pitchFamily="34" charset="-120"/>
               </a:rPr>
-              <a:t>② 課題 ─ 報告と育成に追われ、熟練者が辞めると止まる</a:t>
+              <a:t>課題 ─ 報告と育成に追われ、熟練者が辞めると止まる</a:t>
             </a:r>
             <a:endParaRPr lang="en-US" sz="2000" dirty="0"/>
           </a:p>
@@ -15366,8 +15460,8 @@
         </p:nvSpPr>
         <p:spPr>
           <a:xfrm>
-            <a:off x="8503920" y="4846320"/>
-            <a:ext cx="365760" cy="201168"/>
+            <a:off x="365760" y="4837176"/>
+            <a:ext cx="320040" cy="201168"/>
           </a:xfrm>
           <a:prstGeom prst="rect">
             <a:avLst/>
@@ -15393,7 +15487,7 @@
             </a:lvl1pPr>
           </a:lstStyle>
           <a:p>
-            <a:pPr algn="r"/>
+            <a:pPr algn="l"/>
             <a:fld id="{F7021451-1387-4CA6-816F-3879F97B5CBC}" type="slidenum">
               <a:rPr b="0" lang="en-US"/>
               <a:t>3</a:t>
@@ -15457,13 +15551,30 @@
             <a:r>
               <a:rPr lang="en-US" sz="2000" b="1" dirty="0">
                 <a:solidFill>
+                  <a:srgbClr val="B8692E"/>
+                </a:solidFill>
+                <a:latin typeface="Meiryo" pitchFamily="34" charset="0"/>
+                <a:ea typeface="Meiryo" pitchFamily="34" charset="-122"/>
+                <a:cs typeface="Meiryo" pitchFamily="34" charset="-120"/>
+              </a:rPr>
+              <a:t>③ </a:t>
+            </a:r>
+            <a:pPr algn="l" indent="0" marL="0">
+              <a:lnSpc>
+                <a:spcPct val="115000"/>
+              </a:lnSpc>
+              <a:buNone/>
+            </a:pPr>
+            <a:r>
+              <a:rPr lang="en-US" sz="2000" b="1" dirty="0">
+                <a:solidFill>
                   <a:srgbClr val="1A1A1A"/>
                 </a:solidFill>
                 <a:latin typeface="Meiryo" pitchFamily="34" charset="0"/>
                 <a:ea typeface="Meiryo" pitchFamily="34" charset="-122"/>
                 <a:cs typeface="Meiryo" pitchFamily="34" charset="-120"/>
               </a:rPr>
-              <a:t>③ 解決策 ─ 記録は自動。貯まるほど真似されにくい</a:t>
+              <a:t>解決策 ─ 記録は自動。貯まるほど真似されにくい</a:t>
             </a:r>
             <a:endParaRPr lang="en-US" sz="2000" dirty="0"/>
           </a:p>
@@ -16048,8 +16159,8 @@
         </p:nvSpPr>
         <p:spPr>
           <a:xfrm>
-            <a:off x="8503920" y="4846320"/>
-            <a:ext cx="365760" cy="201168"/>
+            <a:off x="365760" y="4837176"/>
+            <a:ext cx="320040" cy="201168"/>
           </a:xfrm>
           <a:prstGeom prst="rect">
             <a:avLst/>
@@ -16075,7 +16186,7 @@
             </a:lvl1pPr>
           </a:lstStyle>
           <a:p>
-            <a:pPr algn="r"/>
+            <a:pPr algn="l"/>
             <a:fld id="{F7021451-1387-4CA6-816F-3879F97B5CBC}" type="slidenum">
               <a:rPr b="0" lang="en-US"/>
               <a:t>4</a:t>
@@ -16139,13 +16250,30 @@
             <a:r>
               <a:rPr lang="en-US" sz="2000" b="1" dirty="0">
                 <a:solidFill>
+                  <a:srgbClr val="B8692E"/>
+                </a:solidFill>
+                <a:latin typeface="Meiryo" pitchFamily="34" charset="0"/>
+                <a:ea typeface="Meiryo" pitchFamily="34" charset="-122"/>
+                <a:cs typeface="Meiryo" pitchFamily="34" charset="-120"/>
+              </a:rPr>
+              <a:t>③ </a:t>
+            </a:r>
+            <a:pPr algn="l" indent="0" marL="0">
+              <a:lnSpc>
+                <a:spcPct val="115000"/>
+              </a:lnSpc>
+              <a:buNone/>
+            </a:pPr>
+            <a:r>
+              <a:rPr lang="en-US" sz="2000" b="1" dirty="0">
+                <a:solidFill>
                   <a:srgbClr val="1A1A1A"/>
                 </a:solidFill>
                 <a:latin typeface="Meiryo" pitchFamily="34" charset="0"/>
                 <a:ea typeface="Meiryo" pitchFamily="34" charset="-122"/>
                 <a:cs typeface="Meiryo" pitchFamily="34" charset="-120"/>
               </a:rPr>
-              <a:t>③ デモ ─ 図面との差異を見つけ、報告書が自動でできる</a:t>
+              <a:t>デモ ─ 図面との差異を見つけ、報告書が自動でできる</a:t>
             </a:r>
             <a:endParaRPr lang="en-US" sz="2000" dirty="0"/>
           </a:p>
@@ -16691,8 +16819,8 @@
         </p:nvSpPr>
         <p:spPr>
           <a:xfrm>
-            <a:off x="8503920" y="4846320"/>
-            <a:ext cx="365760" cy="201168"/>
+            <a:off x="365760" y="4837176"/>
+            <a:ext cx="320040" cy="201168"/>
           </a:xfrm>
           <a:prstGeom prst="rect">
             <a:avLst/>
@@ -16718,7 +16846,7 @@
             </a:lvl1pPr>
           </a:lstStyle>
           <a:p>
-            <a:pPr algn="r"/>
+            <a:pPr algn="l"/>
             <a:fld id="{F7021451-1387-4CA6-816F-3879F97B5CBC}" type="slidenum">
               <a:rPr b="0" lang="en-US"/>
               <a:t>5</a:t>
@@ -16782,13 +16910,30 @@
             <a:r>
               <a:rPr lang="en-US" sz="2000" b="1" dirty="0">
                 <a:solidFill>
+                  <a:srgbClr val="B8692E"/>
+                </a:solidFill>
+                <a:latin typeface="Meiryo" pitchFamily="34" charset="0"/>
+                <a:ea typeface="Meiryo" pitchFamily="34" charset="-122"/>
+                <a:cs typeface="Meiryo" pitchFamily="34" charset="-120"/>
+              </a:rPr>
+              <a:t>③ </a:t>
+            </a:r>
+            <a:pPr algn="l" indent="0" marL="0">
+              <a:lnSpc>
+                <a:spcPct val="115000"/>
+              </a:lnSpc>
+              <a:buNone/>
+            </a:pPr>
+            <a:r>
+              <a:rPr lang="en-US" sz="2000" b="1" dirty="0">
+                <a:solidFill>
                   <a:srgbClr val="1A1A1A"/>
                 </a:solidFill>
                 <a:latin typeface="Meiryo" pitchFamily="34" charset="0"/>
                 <a:ea typeface="Meiryo" pitchFamily="34" charset="-122"/>
                 <a:cs typeface="Meiryo" pitchFamily="34" charset="-120"/>
               </a:rPr>
-              <a:t>③ 競合 ─ 「貯める」会社は現れた。当社は「渡す」で分かれる</a:t>
+              <a:t>競合 ─ 「貯める」会社は現れた。当社は「渡す」で分かれる</a:t>
             </a:r>
             <a:endParaRPr lang="en-US" sz="2000" dirty="0"/>
           </a:p>
@@ -19652,8 +19797,8 @@
         </p:nvSpPr>
         <p:spPr>
           <a:xfrm>
-            <a:off x="8503920" y="4846320"/>
-            <a:ext cx="365760" cy="201168"/>
+            <a:off x="365760" y="4837176"/>
+            <a:ext cx="320040" cy="201168"/>
           </a:xfrm>
           <a:prstGeom prst="rect">
             <a:avLst/>
@@ -19679,7 +19824,7 @@
             </a:lvl1pPr>
           </a:lstStyle>
           <a:p>
-            <a:pPr algn="r"/>
+            <a:pPr algn="l"/>
             <a:fld id="{F7021451-1387-4CA6-816F-3879F97B5CBC}" type="slidenum">
               <a:rPr b="0" lang="en-US"/>
               <a:t>6</a:t>
@@ -19743,13 +19888,30 @@
             <a:r>
               <a:rPr lang="en-US" sz="2000" b="1" dirty="0">
                 <a:solidFill>
+                  <a:srgbClr val="B8692E"/>
+                </a:solidFill>
+                <a:latin typeface="Meiryo" pitchFamily="34" charset="0"/>
+                <a:ea typeface="Meiryo" pitchFamily="34" charset="-122"/>
+                <a:cs typeface="Meiryo" pitchFamily="34" charset="-120"/>
+              </a:rPr>
+              <a:t>④ </a:t>
+            </a:r>
+            <a:pPr algn="l" indent="0" marL="0">
+              <a:lnSpc>
+                <a:spcPct val="115000"/>
+              </a:lnSpc>
+              <a:buNone/>
+            </a:pPr>
+            <a:r>
+              <a:rPr lang="en-US" sz="2000" b="1" dirty="0">
+                <a:solidFill>
                   <a:srgbClr val="1A1A1A"/>
                 </a:solidFill>
                 <a:latin typeface="Meiryo" pitchFamily="34" charset="0"/>
                 <a:ea typeface="Meiryo" pitchFamily="34" charset="-122"/>
                 <a:cs typeface="Meiryo" pitchFamily="34" charset="-120"/>
               </a:rPr>
-              <a:t>④ 市場規模 ─ 狙う市場は約100億円、周辺は年7〜9%成長</a:t>
+              <a:t>市場規模 ─ 狙う市場は約100億円、周辺は年7〜9%成長</a:t>
             </a:r>
             <a:endParaRPr lang="en-US" sz="2000" dirty="0"/>
           </a:p>
@@ -20295,7 +20457,7 @@
                           <a:ea typeface="Meiryo" pitchFamily="34" charset="-122"/>
                           <a:cs typeface="Meiryo" pitchFamily="34" charset="-120"/>
                         </a:rPr>
-                        <a:t>42億米ドル（2025年）</a:t>
+                        <a:t>42億→92億米ドル</a:t>
                       </a:r>
                       <a:endParaRPr lang="en-US" sz="800" dirty="0">
                         <a:latin typeface="Meiryo" charset="0"/>
@@ -20345,7 +20507,7 @@
                           <a:ea typeface="Meiryo" pitchFamily="34" charset="-122"/>
                           <a:cs typeface="Meiryo" pitchFamily="34" charset="-120"/>
                         </a:rPr>
-                        <a:t>国内スマートファクトリー市場 (1)</a:t>
+                        <a:t>国内スマートファクトリー市場 2025→2034年 (1)</a:t>
                       </a:r>
                       <a:endParaRPr lang="en-US" sz="800" dirty="0">
                         <a:latin typeface="Meiryo" charset="0"/>
@@ -20447,7 +20609,7 @@
                           <a:ea typeface="Meiryo" pitchFamily="34" charset="-122"/>
                           <a:cs typeface="Meiryo" pitchFamily="34" charset="-120"/>
                         </a:rPr>
-                        <a:t>1,845億円→3,000億円超</a:t>
+                        <a:t>1,845億円→3,043億円</a:t>
                       </a:r>
                       <a:endParaRPr lang="en-US" sz="800" dirty="0">
                         <a:latin typeface="Meiryo" charset="0"/>
@@ -20497,7 +20659,7 @@
                           <a:ea typeface="Meiryo" pitchFamily="34" charset="-122"/>
                           <a:cs typeface="Meiryo" pitchFamily="34" charset="-120"/>
                         </a:rPr>
-                        <a:t>国内建設テック市場 2023→2030年度 (2)</a:t>
+                        <a:t>国内建設テック市場（建築分野）2023→2030年度 (2)</a:t>
                       </a:r>
                       <a:endParaRPr lang="en-US" sz="800" dirty="0">
                         <a:latin typeface="Meiryo" charset="0"/>
@@ -20940,7 +21102,7 @@
                 <a:ea typeface="Meiryo" pitchFamily="34" charset="-122"/>
                 <a:cs typeface="Meiryo" pitchFamily="34" charset="-120"/>
               </a:rPr>
-              <a:t>国内スマートファクトリー：年9.0%成長（2026〜2034年予測）(1)</a:t>
+              <a:t>国内スマートファクトリー：年9.03%成長（2026〜2034年予測）(1)</a:t>
             </a:r>
             <a:endParaRPr lang="en-US" sz="850" dirty="0"/>
           </a:p>
@@ -20963,7 +21125,7 @@
                 <a:ea typeface="Meiryo" pitchFamily="34" charset="-122"/>
                 <a:cs typeface="Meiryo" pitchFamily="34" charset="-120"/>
               </a:rPr>
-              <a:t>国内建設テック：年約7.2%成長（2023→2030年度から算出）(2)</a:t>
+              <a:t>国内建設テック（建築分野）：年7.4%成長（2023→2030年度予測）(2)</a:t>
             </a:r>
             <a:endParaRPr lang="en-US" sz="850" dirty="0"/>
           </a:p>
@@ -21000,8 +21162,8 @@
         </p:nvSpPr>
         <p:spPr>
           <a:xfrm>
-            <a:off x="365760" y="4517136"/>
-            <a:ext cx="8412480" cy="292608"/>
+            <a:off x="365760" y="4480560"/>
+            <a:ext cx="8412480" cy="274320"/>
           </a:xfrm>
           <a:prstGeom prst="rect">
             <a:avLst/>
@@ -21028,7 +21190,7 @@
                 <a:ea typeface="Meiryo" pitchFamily="34" charset="-122"/>
                 <a:cs typeface="Meiryo" pitchFamily="34" charset="-120"/>
               </a:rPr>
-              <a:t>(1) IMARC Group（2034年に92億米ドル、年平均9.03%）　(2) 矢野経済研究所　(3) 経済産業省「経済構造実態調査」2024年（従業者10人以上）　(4) 国土交通省「建設業許可業者数調査」の電気工事業63,144社から資本金5,000万円以上を推計（電気通信工事業を含む）</a:t>
+              <a:t>(1) IMARC Group「Japan Smart Factory Market」　(2) 矢野経済研究所 プレスリリースNo.3789（2025年4月）建築分野ソフトウェア　(3) 経済産業省「経済構造実態調査」2024年　(4) 電気工事業の許可業者65,497社（令和7年3月末、国土交通省）から推計</a:t>
             </a:r>
             <a:endParaRPr lang="en-US" sz="800" dirty="0"/>
           </a:p>
@@ -21046,8 +21208,8 @@
         </p:nvSpPr>
         <p:spPr>
           <a:xfrm>
-            <a:off x="8503920" y="4846320"/>
-            <a:ext cx="365760" cy="201168"/>
+            <a:off x="365760" y="4837176"/>
+            <a:ext cx="320040" cy="201168"/>
           </a:xfrm>
           <a:prstGeom prst="rect">
             <a:avLst/>
@@ -21073,7 +21235,7 @@
             </a:lvl1pPr>
           </a:lstStyle>
           <a:p>
-            <a:pPr algn="r"/>
+            <a:pPr algn="l"/>
             <a:fld id="{F7021451-1387-4CA6-816F-3879F97B5CBC}" type="slidenum">
               <a:rPr b="0" lang="en-US"/>
               <a:t>7</a:t>
@@ -21137,13 +21299,30 @@
             <a:r>
               <a:rPr lang="en-US" sz="2000" b="1" dirty="0">
                 <a:solidFill>
+                  <a:srgbClr val="B8692E"/>
+                </a:solidFill>
+                <a:latin typeface="Meiryo" pitchFamily="34" charset="0"/>
+                <a:ea typeface="Meiryo" pitchFamily="34" charset="-122"/>
+                <a:cs typeface="Meiryo" pitchFamily="34" charset="-120"/>
+              </a:rPr>
+              <a:t>⑤ </a:t>
+            </a:r>
+            <a:pPr algn="l" indent="0" marL="0">
+              <a:lnSpc>
+                <a:spcPct val="115000"/>
+              </a:lnSpc>
+              <a:buNone/>
+            </a:pPr>
+            <a:r>
+              <a:rPr lang="en-US" sz="2000" b="1" dirty="0">
+                <a:solidFill>
                   <a:srgbClr val="1A1A1A"/>
                 </a:solidFill>
                 <a:latin typeface="Meiryo" pitchFamily="34" charset="0"/>
                 <a:ea typeface="Meiryo" pitchFamily="34" charset="-122"/>
                 <a:cs typeface="Meiryo" pitchFamily="34" charset="-120"/>
               </a:rPr>
-              <a:t>⑤ ビジネスモデル ─ 年300万円、約2か月で元が取れる</a:t>
+              <a:t>ビジネスモデル ─ 年300万円、約2か月で元が取れる</a:t>
             </a:r>
             <a:endParaRPr lang="en-US" sz="2000" dirty="0"/>
           </a:p>
@@ -22790,8 +22969,8 @@
         </p:nvSpPr>
         <p:spPr>
           <a:xfrm>
-            <a:off x="8503920" y="4846320"/>
-            <a:ext cx="365760" cy="201168"/>
+            <a:off x="365760" y="4837176"/>
+            <a:ext cx="320040" cy="201168"/>
           </a:xfrm>
           <a:prstGeom prst="rect">
             <a:avLst/>
@@ -22817,7 +22996,7 @@
             </a:lvl1pPr>
           </a:lstStyle>
           <a:p>
-            <a:pPr algn="r"/>
+            <a:pPr algn="l"/>
             <a:fld id="{F7021451-1387-4CA6-816F-3879F97B5CBC}" type="slidenum">
               <a:rPr b="0" lang="en-US"/>
               <a:t>8</a:t>
@@ -22881,13 +23060,30 @@
             <a:r>
               <a:rPr lang="en-US" sz="2000" b="1" dirty="0">
                 <a:solidFill>
+                  <a:srgbClr val="B8692E"/>
+                </a:solidFill>
+                <a:latin typeface="Meiryo" pitchFamily="34" charset="0"/>
+                <a:ea typeface="Meiryo" pitchFamily="34" charset="-122"/>
+                <a:cs typeface="Meiryo" pitchFamily="34" charset="-120"/>
+              </a:rPr>
+              <a:t>⑥ </a:t>
+            </a:r>
+            <a:pPr algn="l" indent="0" marL="0">
+              <a:lnSpc>
+                <a:spcPct val="115000"/>
+              </a:lnSpc>
+              <a:buNone/>
+            </a:pPr>
+            <a:r>
+              <a:rPr lang="en-US" sz="2000" b="1" dirty="0">
+                <a:solidFill>
                   <a:srgbClr val="1A1A1A"/>
                 </a:solidFill>
                 <a:latin typeface="Meiryo" pitchFamily="34" charset="0"/>
                 <a:ea typeface="Meiryo" pitchFamily="34" charset="-122"/>
                 <a:cs typeface="Meiryo" pitchFamily="34" charset="-120"/>
               </a:rPr>
-              <a:t>⑥ 売上予測 ─ 拠点×月25万円。5年目は月2,400万円</a:t>
+              <a:t>売上予測 ─ 拠点×月25万円。5年目は月2,400万円</a:t>
             </a:r>
             <a:endParaRPr lang="en-US" sz="2000" dirty="0"/>
           </a:p>
@@ -25346,7 +25542,7 @@
                 <a:ea typeface="Meiryo" pitchFamily="34" charset="-122"/>
                 <a:cs typeface="Meiryo" pitchFamily="34" charset="-120"/>
               </a:rPr>
-              <a:t>人件費は1人年800万円（給与600万円＋法定福利・採用・教育200万円）。家賃は1年目月20万円・5年目月50万円</a:t>
+              <a:t>所在地案：川崎市（準備期は川崎・横浜のインキュベーション施設）。家賃は1年目15坪・月20万円、5年目40坪・月50万円。人件費は1人年800万円</a:t>
             </a:r>
             <a:endParaRPr lang="en-US" sz="800" dirty="0"/>
           </a:p>
@@ -25406,8 +25602,8 @@
         </p:nvSpPr>
         <p:spPr>
           <a:xfrm>
-            <a:off x="8503920" y="4846320"/>
-            <a:ext cx="365760" cy="201168"/>
+            <a:off x="365760" y="4837176"/>
+            <a:ext cx="320040" cy="201168"/>
           </a:xfrm>
           <a:prstGeom prst="rect">
             <a:avLst/>
@@ -25433,7 +25629,7 @@
             </a:lvl1pPr>
           </a:lstStyle>
           <a:p>
-            <a:pPr algn="r"/>
+            <a:pPr algn="l"/>
             <a:fld id="{F7021451-1387-4CA6-816F-3879F97B5CBC}" type="slidenum">
               <a:rPr b="0" lang="en-US"/>
               <a:t>9</a:t>

</xml_diff>

<commit_message>
Add easy (manga) and evidence versions of the Tora pitch deck
- tora_model.js: one financial model that reproduces the plan and runs stress tests
- tora_lib.js: shared slide primitives, manga panels, speech bubbles, character and icon art
- build_tora_easy.js: 14-slide manga version explaining the story and the money flow (300万・255万・2.8拠点)
- build_tora_proof.js: 14-slide evidence version (KPI tree, assumptions, formulas, sensitivity, stress test, sources)
- 収益構造_説明台本.md: speaking scripts (15s/30s/1min/3min) and practice drills
- build_tora.js: break-even and cash figures aligned to the model (92/92/120, 156)

Co-Authored-By: Claude Opus 5.5 <noreply@anthropic.com>
Claude-Session: https://claude.ai/code/session_01Lvjvqoc8h4yHt4F4M6n1V9
</commit_message>
<xml_diff>
--- a/deck/令和の虎_事業計画書_三現ワークス.pptx
+++ b/deck/令和の虎_事業計画書_三現ワークス.pptx
@@ -1491,13 +1491,13 @@
                 <c:formatCode>General</c:formatCode>
                 <c:ptCount val="5"/>
                 <c:pt idx="0">
-                  <c:v>89</c:v>
+                  <c:v>92</c:v>
                 </c:pt>
                 <c:pt idx="1">
-                  <c:v>93</c:v>
+                  <c:v>92</c:v>
                 </c:pt>
                 <c:pt idx="2">
-                  <c:v>119</c:v>
+                  <c:v>120</c:v>
                 </c:pt>
                 <c:pt idx="3">
                   <c:v>151</c:v>
@@ -1786,7 +1786,7 @@
                   <c:v>88</c:v>
                 </c:pt>
                 <c:pt idx="5">
-                  <c:v>157</c:v>
+                  <c:v>156</c:v>
                 </c:pt>
               </c:numCache>
             </c:numRef>
@@ -5828,7 +5828,7 @@
                           <a:ea typeface="Meiryo" pitchFamily="34" charset="-122"/>
                           <a:cs typeface="Meiryo" pitchFamily="34" charset="-120"/>
                         </a:rPr>
-                        <a:t>119</a:t>
+                        <a:t>120</a:t>
                       </a:r>
                       <a:endParaRPr lang="en-US" sz="850" dirty="0">
                         <a:latin typeface="Meiryo" charset="0"/>
@@ -6558,7 +6558,7 @@
                 <a:ea typeface="Meiryo" pitchFamily="34" charset="-122"/>
                 <a:cs typeface="Meiryo" pitchFamily="34" charset="-120"/>
               </a:rPr>
-              <a:t>安全余裕率＝（売上−損益分岐点売上）÷売上。1〜2年目の損益分岐点売上は89・93百万円（売上12・48百万円）</a:t>
+              <a:t>安全余裕率＝（売上−損益分岐点売上）÷売上。1〜2年目の損益分岐点売上は92・92百万円（売上12・48百万円）</a:t>
             </a:r>
             <a:endParaRPr lang="en-US" sz="800" dirty="0"/>
           </a:p>

</xml_diff>